<commit_message>
feat(launcher): add windows exe launcher (pyinstaller) + fix pptx overlaps
</commit_message>
<xml_diff>
--- a/reports/presentation.pptx
+++ b/reports/presentation.pptx
@@ -3522,8 +3522,8 @@
         </p:nvSpPr>
         <p:spPr>
           <a:xfrm>
-            <a:off x="548640" y="1188720"/>
-            <a:ext cx="11064240" cy="5029200"/>
+            <a:off x="640080" y="1188720"/>
+            <a:ext cx="10972800" cy="5303520"/>
           </a:xfrm>
           <a:prstGeom prst="rect">
             <a:avLst/>
@@ -3544,11 +3544,11 @@
                 </a:solidFill>
                 <a:latin typeface="Calibri"/>
               </a:rPr>
-              <a:t>→  MVP complet · pipeline + 4 modèles + dashboard + API + rapport
-→  Tâches bonus livrées · multi-classe failure_type + régression RUL
-→  Hyperparameter tuning Optuna + threshold métier optimisé (FN/FP)
-→  Limites : drift temporel non géré, événements rares sous-représentés
-→  Suite : monitoring drift, RNN / LSTM temporel, intégration GMAO</a:t>
+              <a:t>•  MVP complet · pipeline + 4 modèles + dashboard + API + rapport
+•  Tâches bonus livrées · multi-classe failure_type + régression RUL
+•  Hyperparameter tuning Optuna + threshold métier optimisé (FN/FP)
+•  Limites : drift temporel non géré, événements rares sous-représentés
+•  Suite : monitoring drift, RNN / LSTM temporel, intégration GMAO</a:t>
             </a:r>
           </a:p>
         </p:txBody>
@@ -3847,8 +3847,8 @@
         </p:nvSpPr>
         <p:spPr>
           <a:xfrm>
-            <a:off x="548640" y="1188720"/>
-            <a:ext cx="11064240" cy="5029200"/>
+            <a:off x="640080" y="1188720"/>
+            <a:ext cx="10972800" cy="5303520"/>
           </a:xfrm>
           <a:prstGeom prst="rect">
             <a:avLst/>
@@ -3869,11 +3869,11 @@
                 </a:solidFill>
                 <a:latin typeface="Calibri"/>
               </a:rPr>
-              <a:t>→  Capteurs IoT industriels génèrent en continu vibration / température / pression / RPM.
-→  Une panne non anticipée provoque arrêt non planifié, coût correctif et perte de production.
-→  Cible retenue : classification binaire `failure_within_24h` (panne dans 24h).
-→  Tâches bonus : multi-classe `failure_type` + régression `rul_hours`.
-→  Objectif : transformer le signal capteur en alerte exploitable → décision proactive.</a:t>
+              <a:t>•  Capteurs IoT industriels · vibration / température / pression / RPM en continu.
+•  Une panne non anticipée provoque arrêt non planifié, coût correctif élevé.
+•  Cible retenue : classification binaire failure_within_24h.
+•  Tâches bonus : multi-classe failure_type + régression rul_hours.
+•  Objectif : transformer le signal capteur en alerte exploitable.</a:t>
             </a:r>
           </a:p>
         </p:txBody>
@@ -3990,8 +3990,8 @@
         </p:blipFill>
         <p:spPr>
           <a:xfrm>
-            <a:off x="457200" y="1097280"/>
-            <a:ext cx="11247120" cy="4806323"/>
+            <a:off x="531106" y="1097280"/>
+            <a:ext cx="11126739" cy="4754880"/>
           </a:xfrm>
           <a:prstGeom prst="rect">
             <a:avLst/>
@@ -4006,7 +4006,7 @@
         </p:nvSpPr>
         <p:spPr>
           <a:xfrm>
-            <a:off x="457200" y="6126480"/>
+            <a:off x="457200" y="6035040"/>
             <a:ext cx="11247120" cy="548640"/>
           </a:xfrm>
           <a:prstGeom prst="rect">
@@ -4161,8 +4161,8 @@
         </p:nvSpPr>
         <p:spPr>
           <a:xfrm>
-            <a:off x="457200" y="4937760"/>
-            <a:ext cx="11247120" cy="1371600"/>
+            <a:off x="731520" y="4931839"/>
+            <a:ext cx="10698480" cy="1645920"/>
           </a:xfrm>
           <a:prstGeom prst="rect">
             <a:avLst/>
@@ -4175,15 +4175,18 @@
           </a:bodyPr>
           <a:lstStyle/>
           <a:p>
-            <a:pPr algn="ctr"/>
-            <a:r>
-              <a:rPr sz="1400" b="0">
+            <a:pPr algn="l"/>
+            <a:r>
+              <a:rPr sz="1500" b="0">
                 <a:solidFill>
                   <a:srgbClr val="212121"/>
                 </a:solidFill>
                 <a:latin typeface="Calibri"/>
               </a:rPr>
-              <a:t>Logistic Regression · baseline interprétable  ·  Random Forest · ensemble d'arbres, capture les non-linéarités  ·  XGBoost · gradient boosting, état de l'art tabulaire  ·  MLP 64-32-16 · Deep Learning (early stopping, alpha = 1e-3)</a:t>
+              <a:t>•  Logistic Regression · baseline interprétable
+•  Random Forest · ensemble d'arbres, capture les non-linéarités
+•  XGBoost · gradient boosting, état de l'art tabulaire
+•  MLP 64-32-16 · Deep Learning (early stopping, alpha = 1e-3)</a:t>
             </a:r>
           </a:p>
         </p:txBody>
@@ -4300,8 +4303,8 @@
         </p:blipFill>
         <p:spPr>
           <a:xfrm>
-            <a:off x="457200" y="1097280"/>
-            <a:ext cx="11247120" cy="6081012"/>
+            <a:off x="1866410" y="1005840"/>
+            <a:ext cx="8456131" cy="4572000"/>
           </a:xfrm>
           <a:prstGeom prst="rect">
             <a:avLst/>
@@ -4316,7 +4319,7 @@
         </p:nvSpPr>
         <p:spPr>
           <a:xfrm>
-            <a:off x="457200" y="6035040"/>
+            <a:off x="457200" y="5806440"/>
             <a:ext cx="11247120" cy="548640"/>
           </a:xfrm>
           <a:prstGeom prst="rect">
@@ -4456,7 +4459,7 @@
         <p:spPr>
           <a:xfrm>
             <a:off x="274320" y="1005840"/>
-            <a:ext cx="5852160" cy="4365662"/>
+            <a:ext cx="5852160" cy="4365661"/>
           </a:xfrm>
           <a:prstGeom prst="rect">
             <a:avLst/>
@@ -4480,7 +4483,7 @@
         <p:spPr>
           <a:xfrm>
             <a:off x="6126480" y="1005840"/>
-            <a:ext cx="5852160" cy="4355785"/>
+            <a:ext cx="5852160" cy="4355784"/>
           </a:xfrm>
           <a:prstGeom prst="rect">
             <a:avLst/>
@@ -4599,8 +4602,8 @@
         </p:blipFill>
         <p:spPr>
           <a:xfrm>
-            <a:off x="457200" y="1005840"/>
-            <a:ext cx="6400800" cy="4807637"/>
+            <a:off x="274320" y="1005840"/>
+            <a:ext cx="6400800" cy="4807636"/>
           </a:xfrm>
           <a:prstGeom prst="rect">
             <a:avLst/>
@@ -4623,8 +4626,8 @@
         </p:blipFill>
         <p:spPr>
           <a:xfrm>
-            <a:off x="7040880" y="1371600"/>
-            <a:ext cx="4846320" cy="3599289"/>
+            <a:off x="6858000" y="1280160"/>
+            <a:ext cx="5029200" cy="3735111"/>
           </a:xfrm>
           <a:prstGeom prst="rect">
             <a:avLst/>
@@ -4639,7 +4642,7 @@
         </p:nvSpPr>
         <p:spPr>
           <a:xfrm>
-            <a:off x="457200" y="6217920"/>
+            <a:off x="457200" y="5996356"/>
             <a:ext cx="11247120" cy="457200"/>
           </a:xfrm>
           <a:prstGeom prst="rect">
@@ -4770,8 +4773,8 @@
         </p:nvSpPr>
         <p:spPr>
           <a:xfrm>
-            <a:off x="548640" y="1188720"/>
-            <a:ext cx="11064240" cy="5029200"/>
+            <a:off x="640080" y="1188720"/>
+            <a:ext cx="10972800" cy="5303520"/>
           </a:xfrm>
           <a:prstGeom prst="rect">
             <a:avLst/>
@@ -4792,10 +4795,10 @@
                 </a:solidFill>
                 <a:latin typeface="Calibri"/>
               </a:rPr>
-              <a:t>→  Dashboard Streamlit · 5 onglets, CSS personnalisé charte EFREI
-→  API REST FastAPI · /predict, /health, /model-info (Pydantic v2)
-→  Architecture front -&gt; API -&gt; modèle (joblib) reproduisant un environnement de production
-→  Container Docker + docker-compose pour reproductibilité (`docker compose up`)</a:t>
+              <a:t>•  Dashboard Streamlit · 5 onglets, CSS personnalisé charte EFREI
+•  API REST FastAPI · /predict, /health, /model-info (Pydantic v2)
+•  Architecture front → API → modèle (joblib), pratiques production
+•  Container Docker + docker-compose, démarrage en docker compose up</a:t>
             </a:r>
           </a:p>
         </p:txBody>
@@ -4912,8 +4915,8 @@
         </p:blipFill>
         <p:spPr>
           <a:xfrm>
-            <a:off x="457200" y="1005840"/>
-            <a:ext cx="11247120" cy="4677894"/>
+            <a:off x="598217" y="1005840"/>
+            <a:ext cx="10992517" cy="4572000"/>
           </a:xfrm>
           <a:prstGeom prst="rect">
             <a:avLst/>
@@ -4928,7 +4931,7 @@
         </p:nvSpPr>
         <p:spPr>
           <a:xfrm>
-            <a:off x="457200" y="6126480"/>
+            <a:off x="457200" y="5806440"/>
             <a:ext cx="11247120" cy="457200"/>
           </a:xfrm>
           <a:prstGeom prst="rect">

</xml_diff>

<commit_message>
feat(data): migrate to official kaggle dataset v3.0 (24042 rows, 15 cols, real CC0)
</commit_message>
<xml_diff>
--- a/reports/presentation.pptx
+++ b/reports/presentation.pptx
@@ -4341,7 +4341,7 @@
                 </a:solidFill>
                 <a:latin typeface="Calibri"/>
               </a:rPr>
-              <a:t>Modèle candidat retenu : random_forest (compromis F1 / stabilité CV / interprétabilité)</a:t>
+              <a:t>Modèle candidat retenu : xgboost (compromis F1 / stabilité CV / interprétabilité)</a:t>
             </a:r>
           </a:p>
         </p:txBody>
@@ -4588,7 +4588,7 @@
       </p:sp>
       <p:pic>
         <p:nvPicPr>
-          <p:cNvPr id="4" name="Picture 3" descr="shap_summary_random_forest.png"/>
+          <p:cNvPr id="4" name="Picture 3" descr="shap_summary_xgboost.png"/>
           <p:cNvPicPr>
             <a:picLocks noChangeAspect="1"/>
           </p:cNvPicPr>
@@ -4603,7 +4603,7 @@
         <p:spPr>
           <a:xfrm>
             <a:off x="274320" y="1005840"/>
-            <a:ext cx="6400800" cy="4807636"/>
+            <a:ext cx="6400800" cy="4778219"/>
           </a:xfrm>
           <a:prstGeom prst="rect">
             <a:avLst/>
@@ -4612,7 +4612,7 @@
       </p:pic>
       <p:pic>
         <p:nvPicPr>
-          <p:cNvPr id="5" name="Picture 4" descr="shap_bar_random_forest.png"/>
+          <p:cNvPr id="5" name="Picture 4" descr="shap_bar_xgboost.png"/>
           <p:cNvPicPr>
             <a:picLocks noChangeAspect="1"/>
           </p:cNvPicPr>
@@ -4627,7 +4627,7 @@
         <p:spPr>
           <a:xfrm>
             <a:off x="6858000" y="1280160"/>
-            <a:ext cx="5029200" cy="3735111"/>
+            <a:ext cx="5029200" cy="3738328"/>
           </a:xfrm>
           <a:prstGeom prst="rect">
             <a:avLst/>
@@ -4642,7 +4642,7 @@
         </p:nvSpPr>
         <p:spPr>
           <a:xfrm>
-            <a:off x="457200" y="5996356"/>
+            <a:off x="457200" y="5966939"/>
             <a:ext cx="11247120" cy="457200"/>
           </a:xfrm>
           <a:prstGeom prst="rect">

</xml_diff>

<commit_message>
docs(slides): regen pptx with student ids on title and qa slides
</commit_message>
<xml_diff>
--- a/reports/presentation.pptx
+++ b/reports/presentation.pptx
@@ -5421,7 +5421,7 @@
                 </a:solidFill>
                 <a:latin typeface="Calibri"/>
               </a:rPr>
-              <a:t>Adam BELOUCIF  ·  Emilien MORICE</a:t>
+              <a:t>Adam BELOUCIF (20220055)  ·  Emilien MORICE (20241824)</a:t>
             </a:r>
           </a:p>
         </p:txBody>
@@ -8641,8 +8641,8 @@
                 </a:solidFill>
                 <a:latin typeface="Calibri"/>
               </a:rPr>
-              <a:t>Adam BELOUCIF · adam.beloucif@efrei.net
-Emilien MORICE · emilien.morice@efrei.net</a:t>
+              <a:t>Adam BELOUCIF (N° 20220055) · adam.beloucif@efrei.net
+Emilien MORICE (N° 20241824) · emilien.morice@efrei.net</a:t>
             </a:r>
           </a:p>
         </p:txBody>

</xml_diff>